<commit_message>
progess on bands and edge states
</commit_message>
<xml_diff>
--- a/meeting_notes/understanding_edge-states.pptx
+++ b/meeting_notes/understanding_edge-states.pptx
@@ -10,11 +10,10 @@
     <p:sldId id="261" r:id="rId4"/>
     <p:sldId id="262" r:id="rId5"/>
     <p:sldId id="263" r:id="rId6"/>
-    <p:sldId id="264" r:id="rId7"/>
-    <p:sldId id="265" r:id="rId8"/>
-    <p:sldId id="259" r:id="rId9"/>
-    <p:sldId id="258" r:id="rId10"/>
-    <p:sldId id="260" r:id="rId11"/>
+    <p:sldId id="265" r:id="rId7"/>
+    <p:sldId id="259" r:id="rId8"/>
+    <p:sldId id="258" r:id="rId9"/>
+    <p:sldId id="260" r:id="rId10"/>
   </p:sldIdLst>
   <p:sldSz cx="12192000" cy="6858000"/>
   <p:notesSz cx="6858000" cy="9144000"/>
@@ -113,6 +112,11 @@
       </a:defRPr>
     </a:lvl9pPr>
   </p:defaultTextStyle>
+  <p:extLst>
+    <p:ext uri="{EFAFB233-063F-42B5-8137-9DF3F51BA10A}">
+      <p15:sldGuideLst xmlns:p15="http://schemas.microsoft.com/office/powerpoint/2012/main"/>
+    </p:ext>
+  </p:extLst>
 </p:presentation>
 </file>
 
@@ -263,7 +267,7 @@
           <a:p>
             <a:fld id="{A173AD31-BB2E-40F5-82E9-D96EB5B1234D}" type="datetimeFigureOut">
               <a:rPr lang="en-US" smtClean="0"/>
-              <a:t>3/19/2026</a:t>
+              <a:t>3/23/2026</a:t>
             </a:fld>
             <a:endParaRPr lang="en-US"/>
           </a:p>
@@ -461,7 +465,7 @@
           <a:p>
             <a:fld id="{A173AD31-BB2E-40F5-82E9-D96EB5B1234D}" type="datetimeFigureOut">
               <a:rPr lang="en-US" smtClean="0"/>
-              <a:t>3/19/2026</a:t>
+              <a:t>3/23/2026</a:t>
             </a:fld>
             <a:endParaRPr lang="en-US"/>
           </a:p>
@@ -669,7 +673,7 @@
           <a:p>
             <a:fld id="{A173AD31-BB2E-40F5-82E9-D96EB5B1234D}" type="datetimeFigureOut">
               <a:rPr lang="en-US" smtClean="0"/>
-              <a:t>3/19/2026</a:t>
+              <a:t>3/23/2026</a:t>
             </a:fld>
             <a:endParaRPr lang="en-US"/>
           </a:p>
@@ -867,7 +871,7 @@
           <a:p>
             <a:fld id="{A173AD31-BB2E-40F5-82E9-D96EB5B1234D}" type="datetimeFigureOut">
               <a:rPr lang="en-US" smtClean="0"/>
-              <a:t>3/19/2026</a:t>
+              <a:t>3/23/2026</a:t>
             </a:fld>
             <a:endParaRPr lang="en-US"/>
           </a:p>
@@ -1142,7 +1146,7 @@
           <a:p>
             <a:fld id="{A173AD31-BB2E-40F5-82E9-D96EB5B1234D}" type="datetimeFigureOut">
               <a:rPr lang="en-US" smtClean="0"/>
-              <a:t>3/19/2026</a:t>
+              <a:t>3/23/2026</a:t>
             </a:fld>
             <a:endParaRPr lang="en-US"/>
           </a:p>
@@ -1407,7 +1411,7 @@
           <a:p>
             <a:fld id="{A173AD31-BB2E-40F5-82E9-D96EB5B1234D}" type="datetimeFigureOut">
               <a:rPr lang="en-US" smtClean="0"/>
-              <a:t>3/19/2026</a:t>
+              <a:t>3/23/2026</a:t>
             </a:fld>
             <a:endParaRPr lang="en-US"/>
           </a:p>
@@ -1819,7 +1823,7 @@
           <a:p>
             <a:fld id="{A173AD31-BB2E-40F5-82E9-D96EB5B1234D}" type="datetimeFigureOut">
               <a:rPr lang="en-US" smtClean="0"/>
-              <a:t>3/19/2026</a:t>
+              <a:t>3/23/2026</a:t>
             </a:fld>
             <a:endParaRPr lang="en-US"/>
           </a:p>
@@ -1960,7 +1964,7 @@
           <a:p>
             <a:fld id="{A173AD31-BB2E-40F5-82E9-D96EB5B1234D}" type="datetimeFigureOut">
               <a:rPr lang="en-US" smtClean="0"/>
-              <a:t>3/19/2026</a:t>
+              <a:t>3/23/2026</a:t>
             </a:fld>
             <a:endParaRPr lang="en-US"/>
           </a:p>
@@ -2073,7 +2077,7 @@
           <a:p>
             <a:fld id="{A173AD31-BB2E-40F5-82E9-D96EB5B1234D}" type="datetimeFigureOut">
               <a:rPr lang="en-US" smtClean="0"/>
-              <a:t>3/19/2026</a:t>
+              <a:t>3/23/2026</a:t>
             </a:fld>
             <a:endParaRPr lang="en-US"/>
           </a:p>
@@ -2384,7 +2388,7 @@
           <a:p>
             <a:fld id="{A173AD31-BB2E-40F5-82E9-D96EB5B1234D}" type="datetimeFigureOut">
               <a:rPr lang="en-US" smtClean="0"/>
-              <a:t>3/19/2026</a:t>
+              <a:t>3/23/2026</a:t>
             </a:fld>
             <a:endParaRPr lang="en-US"/>
           </a:p>
@@ -2672,7 +2676,7 @@
           <a:p>
             <a:fld id="{A173AD31-BB2E-40F5-82E9-D96EB5B1234D}" type="datetimeFigureOut">
               <a:rPr lang="en-US" smtClean="0"/>
-              <a:t>3/19/2026</a:t>
+              <a:t>3/23/2026</a:t>
             </a:fld>
             <a:endParaRPr lang="en-US"/>
           </a:p>
@@ -2913,7 +2917,7 @@
           <a:p>
             <a:fld id="{A173AD31-BB2E-40F5-82E9-D96EB5B1234D}" type="datetimeFigureOut">
               <a:rPr lang="en-US" smtClean="0"/>
-              <a:t>3/19/2026</a:t>
+              <a:t>3/23/2026</a:t>
             </a:fld>
             <a:endParaRPr lang="en-US"/>
           </a:p>
@@ -3400,124 +3404,6 @@
 </p:sld>
 </file>
 
-<file path=ppt/slides/slide10.xml><?xml version="1.0" encoding="utf-8"?>
-<p:sld xmlns:a="http://schemas.openxmlformats.org/drawingml/2006/main" xmlns:r="http://schemas.openxmlformats.org/officeDocument/2006/relationships" xmlns:p="http://schemas.openxmlformats.org/presentationml/2006/main">
-  <p:cSld>
-    <p:spTree>
-      <p:nvGrpSpPr>
-        <p:cNvPr id="1" name="">
-          <a:extLst>
-            <a:ext uri="{FF2B5EF4-FFF2-40B4-BE49-F238E27FC236}">
-              <a16:creationId xmlns:a16="http://schemas.microsoft.com/office/drawing/2014/main" id="{02D287EA-9F85-6CAB-BDDB-950ACFC90BB3}"/>
-            </a:ext>
-          </a:extLst>
-        </p:cNvPr>
-        <p:cNvGrpSpPr/>
-        <p:nvPr/>
-      </p:nvGrpSpPr>
-      <p:grpSpPr>
-        <a:xfrm>
-          <a:off x="0" y="0"/>
-          <a:ext cx="0" cy="0"/>
-          <a:chOff x="0" y="0"/>
-          <a:chExt cx="0" cy="0"/>
-        </a:xfrm>
-      </p:grpSpPr>
-      <p:sp>
-        <p:nvSpPr>
-          <p:cNvPr id="2" name="Title 1">
-            <a:extLst>
-              <a:ext uri="{FF2B5EF4-FFF2-40B4-BE49-F238E27FC236}">
-                <a16:creationId xmlns:a16="http://schemas.microsoft.com/office/drawing/2014/main" id="{12A111CD-AD52-1B44-E31D-47677E6FECF9}"/>
-              </a:ext>
-            </a:extLst>
-          </p:cNvPr>
-          <p:cNvSpPr>
-            <a:spLocks noGrp="1"/>
-          </p:cNvSpPr>
-          <p:nvPr>
-            <p:ph type="title"/>
-          </p:nvPr>
-        </p:nvSpPr>
-        <p:spPr/>
-        <p:txBody>
-          <a:bodyPr/>
-          <a:lstStyle/>
-          <a:p>
-            <a:r>
-              <a:rPr lang="en-US" dirty="0"/>
-              <a:t>Same calculation again</a:t>
-            </a:r>
-            <a:br>
-              <a:rPr lang="en-US" dirty="0"/>
-            </a:br>
-            <a:r>
-              <a:rPr lang="en-US" dirty="0"/>
-              <a:t>smaller steps : 4 </a:t>
-            </a:r>
-            <a:r>
-              <a:rPr lang="en-US" dirty="0">
-                <a:sym typeface="Wingdings" panose="05000000000000000000" pitchFamily="2" charset="2"/>
-              </a:rPr>
-              <a:t></a:t>
-            </a:r>
-            <a:r>
-              <a:rPr lang="en-US" dirty="0"/>
-              <a:t> 2</a:t>
-            </a:r>
-          </a:p>
-        </p:txBody>
-      </p:sp>
-      <p:pic>
-        <p:nvPicPr>
-          <p:cNvPr id="8" name="Content Placeholder 7">
-            <a:extLst>
-              <a:ext uri="{FF2B5EF4-FFF2-40B4-BE49-F238E27FC236}">
-                <a16:creationId xmlns:a16="http://schemas.microsoft.com/office/drawing/2014/main" id="{CD10E34A-77A6-B2A3-261E-E7C5575AB12F}"/>
-              </a:ext>
-            </a:extLst>
-          </p:cNvPr>
-          <p:cNvPicPr>
-            <a:picLocks noGrp="1" noChangeAspect="1"/>
-          </p:cNvPicPr>
-          <p:nvPr>
-            <p:ph sz="half" idx="2"/>
-          </p:nvPr>
-        </p:nvPicPr>
-        <p:blipFill>
-          <a:blip r:embed="rId2">
-            <a:extLst>
-              <a:ext uri="{28A0092B-C50C-407E-A947-70E740481C1C}">
-                <a14:useLocalDpi xmlns:a14="http://schemas.microsoft.com/office/drawing/2010/main" val="0"/>
-              </a:ext>
-            </a:extLst>
-          </a:blip>
-          <a:srcRect/>
-          <a:stretch/>
-        </p:blipFill>
-        <p:spPr>
-          <a:xfrm>
-            <a:off x="581171" y="1960669"/>
-            <a:ext cx="6364576" cy="4203429"/>
-          </a:xfrm>
-          <a:prstGeom prst="rect">
-            <a:avLst/>
-          </a:prstGeom>
-        </p:spPr>
-      </p:pic>
-    </p:spTree>
-    <p:extLst>
-      <p:ext uri="{BB962C8B-B14F-4D97-AF65-F5344CB8AC3E}">
-        <p14:creationId xmlns:p14="http://schemas.microsoft.com/office/powerpoint/2010/main" val="3948921700"/>
-      </p:ext>
-    </p:extLst>
-  </p:cSld>
-  <p:clrMapOvr>
-    <a:masterClrMapping/>
-  </p:clrMapOvr>
-</p:sld>
-</file>
-
 <file path=ppt/slides/slide2.xml><?xml version="1.0" encoding="utf-8"?>
 <p:sld xmlns:a="http://schemas.openxmlformats.org/drawingml/2006/main" xmlns:r="http://schemas.openxmlformats.org/officeDocument/2006/relationships" xmlns:p="http://schemas.openxmlformats.org/presentationml/2006/main">
   <p:cSld>
@@ -4528,200 +4414,6 @@
   <p:cSld>
     <p:spTree>
       <p:nvGrpSpPr>
-        <p:cNvPr id="1" name="">
-          <a:extLst>
-            <a:ext uri="{FF2B5EF4-FFF2-40B4-BE49-F238E27FC236}">
-              <a16:creationId xmlns:a16="http://schemas.microsoft.com/office/drawing/2014/main" id="{81C55358-4434-3140-4198-4996A8638EB6}"/>
-            </a:ext>
-          </a:extLst>
-        </p:cNvPr>
-        <p:cNvGrpSpPr/>
-        <p:nvPr/>
-      </p:nvGrpSpPr>
-      <p:grpSpPr>
-        <a:xfrm>
-          <a:off x="0" y="0"/>
-          <a:ext cx="0" cy="0"/>
-          <a:chOff x="0" y="0"/>
-          <a:chExt cx="0" cy="0"/>
-        </a:xfrm>
-      </p:grpSpPr>
-      <p:sp>
-        <p:nvSpPr>
-          <p:cNvPr id="2" name="Title 1">
-            <a:extLst>
-              <a:ext uri="{FF2B5EF4-FFF2-40B4-BE49-F238E27FC236}">
-                <a16:creationId xmlns:a16="http://schemas.microsoft.com/office/drawing/2014/main" id="{E0D5EDD1-AD89-7C71-8480-D98D54B92872}"/>
-              </a:ext>
-            </a:extLst>
-          </p:cNvPr>
-          <p:cNvSpPr>
-            <a:spLocks noGrp="1"/>
-          </p:cNvSpPr>
-          <p:nvPr>
-            <p:ph type="title"/>
-          </p:nvPr>
-        </p:nvSpPr>
-        <p:spPr/>
-        <p:txBody>
-          <a:bodyPr/>
-          <a:lstStyle/>
-          <a:p>
-            <a:r>
-              <a:rPr lang="en-US" dirty="0"/>
-              <a:t>BS: energy</a:t>
-            </a:r>
-          </a:p>
-        </p:txBody>
-      </p:sp>
-      <p:sp>
-        <p:nvSpPr>
-          <p:cNvPr id="3" name="Text Placeholder 2">
-            <a:extLst>
-              <a:ext uri="{FF2B5EF4-FFF2-40B4-BE49-F238E27FC236}">
-                <a16:creationId xmlns:a16="http://schemas.microsoft.com/office/drawing/2014/main" id="{D9D7C3FC-8846-5E3D-F212-37435E5DD101}"/>
-              </a:ext>
-            </a:extLst>
-          </p:cNvPr>
-          <p:cNvSpPr>
-            <a:spLocks noGrp="1"/>
-          </p:cNvSpPr>
-          <p:nvPr>
-            <p:ph type="body" idx="1"/>
-          </p:nvPr>
-        </p:nvSpPr>
-        <p:spPr/>
-        <p:txBody>
-          <a:bodyPr/>
-          <a:lstStyle/>
-          <a:p>
-            <a:r>
-              <a:rPr lang="en-US" dirty="0"/>
-              <a:t>Armchair</a:t>
-            </a:r>
-          </a:p>
-        </p:txBody>
-      </p:sp>
-      <p:pic>
-        <p:nvPicPr>
-          <p:cNvPr id="10" name="Content Placeholder 9">
-            <a:extLst>
-              <a:ext uri="{FF2B5EF4-FFF2-40B4-BE49-F238E27FC236}">
-                <a16:creationId xmlns:a16="http://schemas.microsoft.com/office/drawing/2014/main" id="{F72014B0-9308-EDA0-1027-01CC2695DD44}"/>
-              </a:ext>
-            </a:extLst>
-          </p:cNvPr>
-          <p:cNvPicPr>
-            <a:picLocks noGrp="1" noChangeAspect="1"/>
-          </p:cNvPicPr>
-          <p:nvPr>
-            <p:ph sz="half" idx="2"/>
-          </p:nvPr>
-        </p:nvPicPr>
-        <p:blipFill>
-          <a:blip r:embed="rId2">
-            <a:extLst>
-              <a:ext uri="{28A0092B-C50C-407E-A947-70E740481C1C}">
-                <a14:useLocalDpi xmlns:a14="http://schemas.microsoft.com/office/drawing/2010/main" val="0"/>
-              </a:ext>
-            </a:extLst>
-          </a:blip>
-          <a:srcRect/>
-          <a:stretch/>
-        </p:blipFill>
-        <p:spPr>
-          <a:xfrm>
-            <a:off x="839788" y="2788809"/>
-            <a:ext cx="5157787" cy="3117119"/>
-          </a:xfrm>
-          <a:prstGeom prst="rect">
-            <a:avLst/>
-          </a:prstGeom>
-        </p:spPr>
-      </p:pic>
-      <p:sp>
-        <p:nvSpPr>
-          <p:cNvPr id="5" name="Text Placeholder 4">
-            <a:extLst>
-              <a:ext uri="{FF2B5EF4-FFF2-40B4-BE49-F238E27FC236}">
-                <a16:creationId xmlns:a16="http://schemas.microsoft.com/office/drawing/2014/main" id="{159F94F6-4CF9-0FA7-D19F-D9D45847E082}"/>
-              </a:ext>
-            </a:extLst>
-          </p:cNvPr>
-          <p:cNvSpPr>
-            <a:spLocks noGrp="1"/>
-          </p:cNvSpPr>
-          <p:nvPr>
-            <p:ph type="body" sz="quarter" idx="3"/>
-          </p:nvPr>
-        </p:nvSpPr>
-        <p:spPr/>
-        <p:txBody>
-          <a:bodyPr/>
-          <a:lstStyle/>
-          <a:p>
-            <a:r>
-              <a:rPr lang="en-US" dirty="0"/>
-              <a:t>Zig-zag</a:t>
-            </a:r>
-          </a:p>
-        </p:txBody>
-      </p:sp>
-      <p:pic>
-        <p:nvPicPr>
-          <p:cNvPr id="12" name="Content Placeholder 11">
-            <a:extLst>
-              <a:ext uri="{FF2B5EF4-FFF2-40B4-BE49-F238E27FC236}">
-                <a16:creationId xmlns:a16="http://schemas.microsoft.com/office/drawing/2014/main" id="{FB7036D3-31EE-A370-9886-0056A8747572}"/>
-              </a:ext>
-            </a:extLst>
-          </p:cNvPr>
-          <p:cNvPicPr>
-            <a:picLocks noGrp="1" noChangeAspect="1"/>
-          </p:cNvPicPr>
-          <p:nvPr>
-            <p:ph sz="quarter" idx="4"/>
-          </p:nvPr>
-        </p:nvPicPr>
-        <p:blipFill>
-          <a:blip r:embed="rId3">
-            <a:extLst>
-              <a:ext uri="{28A0092B-C50C-407E-A947-70E740481C1C}">
-                <a14:useLocalDpi xmlns:a14="http://schemas.microsoft.com/office/drawing/2010/main" val="0"/>
-              </a:ext>
-            </a:extLst>
-          </a:blip>
-          <a:srcRect/>
-          <a:stretch/>
-        </p:blipFill>
-        <p:spPr>
-          <a:xfrm>
-            <a:off x="6172200" y="2719965"/>
-            <a:ext cx="5183188" cy="3254807"/>
-          </a:xfrm>
-          <a:prstGeom prst="rect">
-            <a:avLst/>
-          </a:prstGeom>
-        </p:spPr>
-      </p:pic>
-    </p:spTree>
-    <p:extLst>
-      <p:ext uri="{BB962C8B-B14F-4D97-AF65-F5344CB8AC3E}">
-        <p14:creationId xmlns:p14="http://schemas.microsoft.com/office/powerpoint/2010/main" val="1938712475"/>
-      </p:ext>
-    </p:extLst>
-  </p:cSld>
-  <p:clrMapOvr>
-    <a:masterClrMapping/>
-  </p:clrMapOvr>
-</p:sld>
-</file>
-
-<file path=ppt/slides/slide7.xml><?xml version="1.0" encoding="utf-8"?>
-<p:sld xmlns:a="http://schemas.openxmlformats.org/drawingml/2006/main" xmlns:r="http://schemas.openxmlformats.org/officeDocument/2006/relationships" xmlns:p="http://schemas.openxmlformats.org/presentationml/2006/main">
-  <p:cSld>
-    <p:spTree>
-      <p:nvGrpSpPr>
         <p:cNvPr id="1" name=""/>
         <p:cNvGrpSpPr/>
         <p:nvPr/>
@@ -4872,7 +4564,7 @@
 </p:sld>
 </file>
 
-<file path=ppt/slides/slide8.xml><?xml version="1.0" encoding="utf-8"?>
+<file path=ppt/slides/slide7.xml><?xml version="1.0" encoding="utf-8"?>
 <p:sld xmlns:a="http://schemas.openxmlformats.org/drawingml/2006/main" xmlns:r="http://schemas.openxmlformats.org/officeDocument/2006/relationships" xmlns:p="http://schemas.openxmlformats.org/presentationml/2006/main">
   <p:cSld>
     <p:spTree>
@@ -5090,7 +4782,7 @@
 </p:sld>
 </file>
 
-<file path=ppt/slides/slide9.xml><?xml version="1.0" encoding="utf-8"?>
+<file path=ppt/slides/slide8.xml><?xml version="1.0" encoding="utf-8"?>
 <p:sld xmlns:a="http://schemas.openxmlformats.org/drawingml/2006/main" xmlns:r="http://schemas.openxmlformats.org/officeDocument/2006/relationships" xmlns:p="http://schemas.openxmlformats.org/presentationml/2006/main">
   <p:cSld>
     <p:spTree>
@@ -5166,6 +4858,124 @@
         </p:blipFill>
         <p:spPr>
           <a:xfrm>
+            <a:off x="581170" y="1960669"/>
+            <a:ext cx="7218661" cy="4767502"/>
+          </a:xfrm>
+          <a:prstGeom prst="rect">
+            <a:avLst/>
+          </a:prstGeom>
+        </p:spPr>
+      </p:pic>
+    </p:spTree>
+    <p:extLst>
+      <p:ext uri="{BB962C8B-B14F-4D97-AF65-F5344CB8AC3E}">
+        <p14:creationId xmlns:p14="http://schemas.microsoft.com/office/powerpoint/2010/main" val="3024586442"/>
+      </p:ext>
+    </p:extLst>
+  </p:cSld>
+  <p:clrMapOvr>
+    <a:masterClrMapping/>
+  </p:clrMapOvr>
+</p:sld>
+</file>
+
+<file path=ppt/slides/slide9.xml><?xml version="1.0" encoding="utf-8"?>
+<p:sld xmlns:a="http://schemas.openxmlformats.org/drawingml/2006/main" xmlns:r="http://schemas.openxmlformats.org/officeDocument/2006/relationships" xmlns:p="http://schemas.openxmlformats.org/presentationml/2006/main">
+  <p:cSld>
+    <p:spTree>
+      <p:nvGrpSpPr>
+        <p:cNvPr id="1" name="">
+          <a:extLst>
+            <a:ext uri="{FF2B5EF4-FFF2-40B4-BE49-F238E27FC236}">
+              <a16:creationId xmlns:a16="http://schemas.microsoft.com/office/drawing/2014/main" id="{02D287EA-9F85-6CAB-BDDB-950ACFC90BB3}"/>
+            </a:ext>
+          </a:extLst>
+        </p:cNvPr>
+        <p:cNvGrpSpPr/>
+        <p:nvPr/>
+      </p:nvGrpSpPr>
+      <p:grpSpPr>
+        <a:xfrm>
+          <a:off x="0" y="0"/>
+          <a:ext cx="0" cy="0"/>
+          <a:chOff x="0" y="0"/>
+          <a:chExt cx="0" cy="0"/>
+        </a:xfrm>
+      </p:grpSpPr>
+      <p:sp>
+        <p:nvSpPr>
+          <p:cNvPr id="2" name="Title 1">
+            <a:extLst>
+              <a:ext uri="{FF2B5EF4-FFF2-40B4-BE49-F238E27FC236}">
+                <a16:creationId xmlns:a16="http://schemas.microsoft.com/office/drawing/2014/main" id="{12A111CD-AD52-1B44-E31D-47677E6FECF9}"/>
+              </a:ext>
+            </a:extLst>
+          </p:cNvPr>
+          <p:cNvSpPr>
+            <a:spLocks noGrp="1"/>
+          </p:cNvSpPr>
+          <p:nvPr>
+            <p:ph type="title"/>
+          </p:nvPr>
+        </p:nvSpPr>
+        <p:spPr/>
+        <p:txBody>
+          <a:bodyPr/>
+          <a:lstStyle/>
+          <a:p>
+            <a:r>
+              <a:rPr lang="en-US" dirty="0"/>
+              <a:t>Same calculation again</a:t>
+            </a:r>
+            <a:br>
+              <a:rPr lang="en-US" dirty="0"/>
+            </a:br>
+            <a:r>
+              <a:rPr lang="en-US" dirty="0"/>
+              <a:t>smaller steps : 4 </a:t>
+            </a:r>
+            <a:r>
+              <a:rPr lang="en-US" dirty="0">
+                <a:sym typeface="Wingdings" panose="05000000000000000000" pitchFamily="2" charset="2"/>
+              </a:rPr>
+              <a:t></a:t>
+            </a:r>
+            <a:r>
+              <a:rPr lang="en-US" dirty="0"/>
+              <a:t> 2</a:t>
+            </a:r>
+          </a:p>
+        </p:txBody>
+      </p:sp>
+      <p:pic>
+        <p:nvPicPr>
+          <p:cNvPr id="8" name="Content Placeholder 7">
+            <a:extLst>
+              <a:ext uri="{FF2B5EF4-FFF2-40B4-BE49-F238E27FC236}">
+                <a16:creationId xmlns:a16="http://schemas.microsoft.com/office/drawing/2014/main" id="{CD10E34A-77A6-B2A3-261E-E7C5575AB12F}"/>
+              </a:ext>
+            </a:extLst>
+          </p:cNvPr>
+          <p:cNvPicPr>
+            <a:picLocks noGrp="1" noChangeAspect="1"/>
+          </p:cNvPicPr>
+          <p:nvPr>
+            <p:ph sz="half" idx="2"/>
+          </p:nvPr>
+        </p:nvPicPr>
+        <p:blipFill>
+          <a:blip r:embed="rId2">
+            <a:extLst>
+              <a:ext uri="{28A0092B-C50C-407E-A947-70E740481C1C}">
+                <a14:useLocalDpi xmlns:a14="http://schemas.microsoft.com/office/drawing/2010/main" val="0"/>
+              </a:ext>
+            </a:extLst>
+          </a:blip>
+          <a:srcRect/>
+          <a:stretch/>
+        </p:blipFill>
+        <p:spPr>
+          <a:xfrm>
             <a:off x="581171" y="1960669"/>
             <a:ext cx="6364576" cy="4203429"/>
           </a:xfrm>
@@ -5177,7 +4987,7 @@
     </p:spTree>
     <p:extLst>
       <p:ext uri="{BB962C8B-B14F-4D97-AF65-F5344CB8AC3E}">
-        <p14:creationId xmlns:p14="http://schemas.microsoft.com/office/powerpoint/2010/main" val="3024586442"/>
+        <p14:creationId xmlns:p14="http://schemas.microsoft.com/office/powerpoint/2010/main" val="3948921700"/>
       </p:ext>
     </p:extLst>
   </p:cSld>

</xml_diff>

<commit_message>
added some edge related plots
</commit_message>
<xml_diff>
--- a/meeting_notes/understanding_edge-states.pptx
+++ b/meeting_notes/understanding_edge-states.pptx
@@ -14,6 +14,7 @@
     <p:sldId id="259" r:id="rId8"/>
     <p:sldId id="258" r:id="rId9"/>
     <p:sldId id="260" r:id="rId10"/>
+    <p:sldId id="266" r:id="rId11"/>
   </p:sldIdLst>
   <p:sldSz cx="12192000" cy="6858000"/>
   <p:notesSz cx="6858000" cy="9144000"/>
@@ -267,7 +268,7 @@
           <a:p>
             <a:fld id="{A173AD31-BB2E-40F5-82E9-D96EB5B1234D}" type="datetimeFigureOut">
               <a:rPr lang="en-US" smtClean="0"/>
-              <a:t>3/23/2026</a:t>
+              <a:t>4/8/2026</a:t>
             </a:fld>
             <a:endParaRPr lang="en-US"/>
           </a:p>
@@ -465,7 +466,7 @@
           <a:p>
             <a:fld id="{A173AD31-BB2E-40F5-82E9-D96EB5B1234D}" type="datetimeFigureOut">
               <a:rPr lang="en-US" smtClean="0"/>
-              <a:t>3/23/2026</a:t>
+              <a:t>4/8/2026</a:t>
             </a:fld>
             <a:endParaRPr lang="en-US"/>
           </a:p>
@@ -673,7 +674,7 @@
           <a:p>
             <a:fld id="{A173AD31-BB2E-40F5-82E9-D96EB5B1234D}" type="datetimeFigureOut">
               <a:rPr lang="en-US" smtClean="0"/>
-              <a:t>3/23/2026</a:t>
+              <a:t>4/8/2026</a:t>
             </a:fld>
             <a:endParaRPr lang="en-US"/>
           </a:p>
@@ -871,7 +872,7 @@
           <a:p>
             <a:fld id="{A173AD31-BB2E-40F5-82E9-D96EB5B1234D}" type="datetimeFigureOut">
               <a:rPr lang="en-US" smtClean="0"/>
-              <a:t>3/23/2026</a:t>
+              <a:t>4/8/2026</a:t>
             </a:fld>
             <a:endParaRPr lang="en-US"/>
           </a:p>
@@ -1146,7 +1147,7 @@
           <a:p>
             <a:fld id="{A173AD31-BB2E-40F5-82E9-D96EB5B1234D}" type="datetimeFigureOut">
               <a:rPr lang="en-US" smtClean="0"/>
-              <a:t>3/23/2026</a:t>
+              <a:t>4/8/2026</a:t>
             </a:fld>
             <a:endParaRPr lang="en-US"/>
           </a:p>
@@ -1411,7 +1412,7 @@
           <a:p>
             <a:fld id="{A173AD31-BB2E-40F5-82E9-D96EB5B1234D}" type="datetimeFigureOut">
               <a:rPr lang="en-US" smtClean="0"/>
-              <a:t>3/23/2026</a:t>
+              <a:t>4/8/2026</a:t>
             </a:fld>
             <a:endParaRPr lang="en-US"/>
           </a:p>
@@ -1823,7 +1824,7 @@
           <a:p>
             <a:fld id="{A173AD31-BB2E-40F5-82E9-D96EB5B1234D}" type="datetimeFigureOut">
               <a:rPr lang="en-US" smtClean="0"/>
-              <a:t>3/23/2026</a:t>
+              <a:t>4/8/2026</a:t>
             </a:fld>
             <a:endParaRPr lang="en-US"/>
           </a:p>
@@ -1964,7 +1965,7 @@
           <a:p>
             <a:fld id="{A173AD31-BB2E-40F5-82E9-D96EB5B1234D}" type="datetimeFigureOut">
               <a:rPr lang="en-US" smtClean="0"/>
-              <a:t>3/23/2026</a:t>
+              <a:t>4/8/2026</a:t>
             </a:fld>
             <a:endParaRPr lang="en-US"/>
           </a:p>
@@ -2077,7 +2078,7 @@
           <a:p>
             <a:fld id="{A173AD31-BB2E-40F5-82E9-D96EB5B1234D}" type="datetimeFigureOut">
               <a:rPr lang="en-US" smtClean="0"/>
-              <a:t>3/23/2026</a:t>
+              <a:t>4/8/2026</a:t>
             </a:fld>
             <a:endParaRPr lang="en-US"/>
           </a:p>
@@ -2388,7 +2389,7 @@
           <a:p>
             <a:fld id="{A173AD31-BB2E-40F5-82E9-D96EB5B1234D}" type="datetimeFigureOut">
               <a:rPr lang="en-US" smtClean="0"/>
-              <a:t>3/23/2026</a:t>
+              <a:t>4/8/2026</a:t>
             </a:fld>
             <a:endParaRPr lang="en-US"/>
           </a:p>
@@ -2676,7 +2677,7 @@
           <a:p>
             <a:fld id="{A173AD31-BB2E-40F5-82E9-D96EB5B1234D}" type="datetimeFigureOut">
               <a:rPr lang="en-US" smtClean="0"/>
-              <a:t>3/23/2026</a:t>
+              <a:t>4/8/2026</a:t>
             </a:fld>
             <a:endParaRPr lang="en-US"/>
           </a:p>
@@ -2917,7 +2918,7 @@
           <a:p>
             <a:fld id="{A173AD31-BB2E-40F5-82E9-D96EB5B1234D}" type="datetimeFigureOut">
               <a:rPr lang="en-US" smtClean="0"/>
-              <a:t>3/23/2026</a:t>
+              <a:t>4/8/2026</a:t>
             </a:fld>
             <a:endParaRPr lang="en-US"/>
           </a:p>
@@ -3395,6 +3396,164 @@
     <p:extLst>
       <p:ext uri="{BB962C8B-B14F-4D97-AF65-F5344CB8AC3E}">
         <p14:creationId xmlns:p14="http://schemas.microsoft.com/office/powerpoint/2010/main" val="1040712399"/>
+      </p:ext>
+    </p:extLst>
+  </p:cSld>
+  <p:clrMapOvr>
+    <a:masterClrMapping/>
+  </p:clrMapOvr>
+</p:sld>
+</file>
+
+<file path=ppt/slides/slide10.xml><?xml version="1.0" encoding="utf-8"?>
+<p:sld xmlns:a="http://schemas.openxmlformats.org/drawingml/2006/main" xmlns:r="http://schemas.openxmlformats.org/officeDocument/2006/relationships" xmlns:p="http://schemas.openxmlformats.org/presentationml/2006/main">
+  <p:cSld>
+    <p:spTree>
+      <p:nvGrpSpPr>
+        <p:cNvPr id="1" name=""/>
+        <p:cNvGrpSpPr/>
+        <p:nvPr/>
+      </p:nvGrpSpPr>
+      <p:grpSpPr>
+        <a:xfrm>
+          <a:off x="0" y="0"/>
+          <a:ext cx="0" cy="0"/>
+          <a:chOff x="0" y="0"/>
+          <a:chExt cx="0" cy="0"/>
+        </a:xfrm>
+      </p:grpSpPr>
+      <p:sp>
+        <p:nvSpPr>
+          <p:cNvPr id="2" name="Title 1">
+            <a:extLst>
+              <a:ext uri="{FF2B5EF4-FFF2-40B4-BE49-F238E27FC236}">
+                <a16:creationId xmlns:a16="http://schemas.microsoft.com/office/drawing/2014/main" id="{5350C7B4-122A-EB31-4393-45754C01EDE7}"/>
+              </a:ext>
+            </a:extLst>
+          </p:cNvPr>
+          <p:cNvSpPr>
+            <a:spLocks noGrp="1"/>
+          </p:cNvSpPr>
+          <p:nvPr>
+            <p:ph type="title"/>
+          </p:nvPr>
+        </p:nvSpPr>
+        <p:spPr/>
+        <p:txBody>
+          <a:bodyPr/>
+          <a:lstStyle/>
+          <a:p>
+            <a:r>
+              <a:rPr lang="en-US" dirty="0"/>
+              <a:t>Naïve extrapolation</a:t>
+            </a:r>
+          </a:p>
+        </p:txBody>
+      </p:sp>
+      <p:sp>
+        <p:nvSpPr>
+          <p:cNvPr id="3" name="Text Placeholder 2">
+            <a:extLst>
+              <a:ext uri="{FF2B5EF4-FFF2-40B4-BE49-F238E27FC236}">
+                <a16:creationId xmlns:a16="http://schemas.microsoft.com/office/drawing/2014/main" id="{5E816CA7-E664-8F65-2EA5-B0DD18AF2672}"/>
+              </a:ext>
+            </a:extLst>
+          </p:cNvPr>
+          <p:cNvSpPr>
+            <a:spLocks noGrp="1"/>
+          </p:cNvSpPr>
+          <p:nvPr>
+            <p:ph type="body" idx="1"/>
+          </p:nvPr>
+        </p:nvSpPr>
+        <p:spPr/>
+        <p:txBody>
+          <a:bodyPr/>
+          <a:lstStyle/>
+          <a:p>
+            <a:endParaRPr lang="en-US"/>
+          </a:p>
+        </p:txBody>
+      </p:sp>
+      <p:sp>
+        <p:nvSpPr>
+          <p:cNvPr id="4" name="Content Placeholder 3">
+            <a:extLst>
+              <a:ext uri="{FF2B5EF4-FFF2-40B4-BE49-F238E27FC236}">
+                <a16:creationId xmlns:a16="http://schemas.microsoft.com/office/drawing/2014/main" id="{1DFF8BB6-4BF3-1CB7-303D-D8E83DE24F97}"/>
+              </a:ext>
+            </a:extLst>
+          </p:cNvPr>
+          <p:cNvSpPr>
+            <a:spLocks noGrp="1"/>
+          </p:cNvSpPr>
+          <p:nvPr>
+            <p:ph sz="half" idx="2"/>
+          </p:nvPr>
+        </p:nvSpPr>
+        <p:spPr/>
+        <p:txBody>
+          <a:bodyPr/>
+          <a:lstStyle/>
+          <a:p>
+            <a:endParaRPr lang="en-US" dirty="0"/>
+          </a:p>
+        </p:txBody>
+      </p:sp>
+      <p:sp>
+        <p:nvSpPr>
+          <p:cNvPr id="5" name="Text Placeholder 4">
+            <a:extLst>
+              <a:ext uri="{FF2B5EF4-FFF2-40B4-BE49-F238E27FC236}">
+                <a16:creationId xmlns:a16="http://schemas.microsoft.com/office/drawing/2014/main" id="{B64BFEC2-3471-B68F-AC33-49FBAAA1D03F}"/>
+              </a:ext>
+            </a:extLst>
+          </p:cNvPr>
+          <p:cNvSpPr>
+            <a:spLocks noGrp="1"/>
+          </p:cNvSpPr>
+          <p:nvPr>
+            <p:ph type="body" sz="quarter" idx="3"/>
+          </p:nvPr>
+        </p:nvSpPr>
+        <p:spPr/>
+        <p:txBody>
+          <a:bodyPr/>
+          <a:lstStyle/>
+          <a:p>
+            <a:endParaRPr lang="en-US" dirty="0"/>
+          </a:p>
+        </p:txBody>
+      </p:sp>
+      <p:sp>
+        <p:nvSpPr>
+          <p:cNvPr id="6" name="Content Placeholder 5">
+            <a:extLst>
+              <a:ext uri="{FF2B5EF4-FFF2-40B4-BE49-F238E27FC236}">
+                <a16:creationId xmlns:a16="http://schemas.microsoft.com/office/drawing/2014/main" id="{2445E82F-93EE-8979-4553-45D71578C076}"/>
+              </a:ext>
+            </a:extLst>
+          </p:cNvPr>
+          <p:cNvSpPr>
+            <a:spLocks noGrp="1"/>
+          </p:cNvSpPr>
+          <p:nvPr>
+            <p:ph sz="quarter" idx="4"/>
+          </p:nvPr>
+        </p:nvSpPr>
+        <p:spPr/>
+        <p:txBody>
+          <a:bodyPr/>
+          <a:lstStyle/>
+          <a:p>
+            <a:endParaRPr lang="en-US"/>
+          </a:p>
+        </p:txBody>
+      </p:sp>
+    </p:spTree>
+    <p:extLst>
+      <p:ext uri="{BB962C8B-B14F-4D97-AF65-F5344CB8AC3E}">
+        <p14:creationId xmlns:p14="http://schemas.microsoft.com/office/powerpoint/2010/main" val="2263861771"/>
       </p:ext>
     </p:extLst>
   </p:cSld>

</xml_diff>